<commit_message>
Update session labels in index.html for clarity; adjust layout in build scripts for consistency
</commit_message>
<xml_diff>
--- a/contents/Module-07-Database-Maintenance.pptx
+++ b/contents/Module-07-Database-Maintenance.pptx
@@ -5775,7 +5775,7 @@
         </p:nvSpPr>
         <p:spPr>
           <a:xfrm>
-            <a:off x="411480" y="6446520"/>
+            <a:off x="411480" y="6035040"/>
             <a:ext cx="11384280" cy="256032"/>
           </a:xfrm>
           <a:prstGeom prst="rect">
@@ -6263,7 +6263,7 @@
         </p:nvSpPr>
         <p:spPr>
           <a:xfrm>
-            <a:off x="411480" y="5504688"/>
+            <a:off x="411480" y="5394960"/>
             <a:ext cx="228600" cy="228600"/>
           </a:xfrm>
           <a:prstGeom prst="rect">
@@ -6306,7 +6306,7 @@
         </p:nvSpPr>
         <p:spPr>
           <a:xfrm>
-            <a:off x="777240" y="5504688"/>
+            <a:off x="777240" y="5394960"/>
             <a:ext cx="11018520" cy="274320"/>
           </a:xfrm>
           <a:prstGeom prst="rect">
@@ -6341,7 +6341,7 @@
         </p:nvSpPr>
         <p:spPr>
           <a:xfrm>
-            <a:off x="411480" y="5824728"/>
+            <a:off x="411480" y="5650992"/>
             <a:ext cx="228600" cy="228600"/>
           </a:xfrm>
           <a:prstGeom prst="rect">
@@ -6384,7 +6384,7 @@
         </p:nvSpPr>
         <p:spPr>
           <a:xfrm>
-            <a:off x="777240" y="5824728"/>
+            <a:off x="777240" y="5650992"/>
             <a:ext cx="11018520" cy="274320"/>
           </a:xfrm>
           <a:prstGeom prst="rect">
@@ -6419,7 +6419,7 @@
         </p:nvSpPr>
         <p:spPr>
           <a:xfrm>
-            <a:off x="411480" y="6144768"/>
+            <a:off x="411480" y="5907024"/>
             <a:ext cx="228600" cy="228600"/>
           </a:xfrm>
           <a:prstGeom prst="rect">
@@ -6462,7 +6462,7 @@
         </p:nvSpPr>
         <p:spPr>
           <a:xfrm>
-            <a:off x="777240" y="6144768"/>
+            <a:off x="777240" y="5907024"/>
             <a:ext cx="11018520" cy="274320"/>
           </a:xfrm>
           <a:prstGeom prst="rect">
@@ -6497,7 +6497,7 @@
         </p:nvSpPr>
         <p:spPr>
           <a:xfrm>
-            <a:off x="411480" y="6464808"/>
+            <a:off x="411480" y="6163056"/>
             <a:ext cx="228600" cy="228600"/>
           </a:xfrm>
           <a:prstGeom prst="rect">
@@ -6540,7 +6540,7 @@
         </p:nvSpPr>
         <p:spPr>
           <a:xfrm>
-            <a:off x="777240" y="6464808"/>
+            <a:off x="777240" y="6163056"/>
             <a:ext cx="11018520" cy="274320"/>
           </a:xfrm>
           <a:prstGeom prst="rect">

</xml_diff>